<commit_message>
Use exact Excel text for chart labels; remove paraphrased row_labels
- Remove row_labels overrides from Q1 (energy climate) and Q3 (RE outcomes)
  grid slides in wa_energy_annotations.yaml so exact Excel row text is used
  (e.g. "Oil, including diesel and petrol", "New industries",
  "Lowering pollution / addressing climate change", etc.)
- Fix Q1 and Q3 question fields to match verbatim Excel wording
- Fix Q5 question to include full preamble from questionnaire
- Remove duplicate dead-code axis_left block in chart_styles.py

https://claude.ai/code/session_01VCXkWfprNAwES9BXV74rqk
</commit_message>
<xml_diff>
--- a/sample_data/wa_energy_output.pptx
+++ b/sample_data/wa_energy_output.pptx
@@ -8292,7 +8292,7 @@
           <a:lstStyle/>
           <a:p>
             <a:r>
-              <a:t>How bad do you think using each of the following energy types is for the climate? (%)</a:t>
+              <a:t>For each of the following, how bad do you think using the following energy types are for the climate? (%)</a:t>
             </a:r>
           </a:p>
         </p:txBody>
@@ -8897,7 +8897,7 @@
           <a:lstStyle/>
           <a:p>
             <a:r>
-              <a:t>How likely do you think these outcomes would be if WA used more renewable energy? (%)</a:t>
+              <a:t>And how likely do you think these following outcomes would be if WA used more renewable energy? (%)</a:t>
             </a:r>
           </a:p>
         </p:txBody>
@@ -9189,7 +9189,7 @@
           <a:lstStyle/>
           <a:p>
             <a:r>
-              <a:t>How strongly do you support or oppose WA adopting a renewable energy target? (%)</a:t>
+              <a:t>There has been discussion about the WA government setting a target for the generation of renewable energy. How strongly do you support or oppose WA adopting a renewable energy target? (%)</a:t>
             </a:r>
           </a:p>
         </p:txBody>

</xml_diff>

<commit_message>
Fix legend clipping: widen figure by LEGEND_EXTRA_W when legend present
When a legend is present, the chart figure is rendered at fig_w + 2.5"
so all items fit on one row without being clipped. axis_left and
AXIS_RIGHT are scaled proportionally so bar positions stay identical
in absolute inches. The grid chart picture on the slide is placed at
the wider width (cw + LEGEND_EXTRA_W).

https://claude.ai/code/session_01VCXkWfprNAwES9BXV74rqk
</commit_message>
<xml_diff>
--- a/sample_data/wa_energy_output.pptx
+++ b/sample_data/wa_energy_output.pptx
@@ -8335,7 +8335,7 @@
         <p:spPr>
           <a:xfrm>
             <a:off x="310896" y="2199132"/>
-            <a:ext cx="8229600" cy="3657600"/>
+            <a:ext cx="10515600" cy="3657600"/>
           </a:xfrm>
           <a:prstGeom prst="rect">
             <a:avLst/>
@@ -8940,7 +8940,7 @@
         <p:spPr>
           <a:xfrm>
             <a:off x="310896" y="2061972"/>
-            <a:ext cx="8229600" cy="3931920"/>
+            <a:ext cx="10515600" cy="3931920"/>
           </a:xfrm>
           <a:prstGeom prst="rect">
             <a:avLst/>

</xml_diff>

<commit_message>
Chart layout and label colour/size fixes
- _CHART_T: 1.87 → 2.10" to clear 2-line question text; add _CHART_H_MAX=4.60"
  cap so simple-bar charts don't run into the footer
- Grid circle numbers: color changed from teal to #1A1A1A (black)
- Stacked-bar segment labels: 9pt → 14pt white
- Simple-bar labels inside bar: 10pt → 14pt white
- Simple-bar labels beside bar (short bars): 10pt → 14pt #1A1A1A

https://claude.ai/code/session_01VCXkWfprNAwES9BXV74rqk
</commit_message>
<xml_diff>
--- a/sample_data/wa_energy_output.pptx
+++ b/sample_data/wa_energy_output.pptx
@@ -7066,8 +7066,8 @@
           <p:nvPr/>
         </p:nvGraphicFramePr>
         <p:xfrm>
-          <a:off x="310896" y="1709928"/>
-          <a:ext cx="11512295" cy="4645152"/>
+          <a:off x="310896" y="1920240"/>
+          <a:ext cx="11512295" cy="4434840"/>
         </p:xfrm>
         <a:graphic>
           <a:graphicData uri="http://schemas.openxmlformats.org/drawingml/2006/table">
@@ -7079,7 +7079,7 @@
                 <a:gridCol w="9785451"/>
                 <a:gridCol w="1726844"/>
               </a:tblGrid>
-              <a:tr h="309676">
+              <a:tr h="295656">
                 <a:tc>
                   <a:txBody>
                     <a:bodyPr wrap="none"/>
@@ -7127,7 +7127,7 @@
                   </a:tcPr>
                 </a:tc>
               </a:tr>
-              <a:tr h="309676">
+              <a:tr h="295656">
                 <a:tc>
                   <a:txBody>
                     <a:bodyPr wrap="square"/>
@@ -7184,7 +7184,7 @@
                   </a:tcPr>
                 </a:tc>
               </a:tr>
-              <a:tr h="309676">
+              <a:tr h="295656">
                 <a:tc>
                   <a:txBody>
                     <a:bodyPr wrap="square"/>
@@ -7241,7 +7241,7 @@
                   </a:tcPr>
                 </a:tc>
               </a:tr>
-              <a:tr h="309676">
+              <a:tr h="295656">
                 <a:tc>
                   <a:txBody>
                     <a:bodyPr wrap="square"/>
@@ -7298,7 +7298,7 @@
                   </a:tcPr>
                 </a:tc>
               </a:tr>
-              <a:tr h="309676">
+              <a:tr h="295656">
                 <a:tc>
                   <a:txBody>
                     <a:bodyPr wrap="square"/>
@@ -7355,7 +7355,7 @@
                   </a:tcPr>
                 </a:tc>
               </a:tr>
-              <a:tr h="309676">
+              <a:tr h="295656">
                 <a:tc>
                   <a:txBody>
                     <a:bodyPr wrap="square"/>
@@ -7412,7 +7412,7 @@
                   </a:tcPr>
                 </a:tc>
               </a:tr>
-              <a:tr h="309676">
+              <a:tr h="295656">
                 <a:tc>
                   <a:txBody>
                     <a:bodyPr wrap="square"/>
@@ -7469,7 +7469,7 @@
                   </a:tcPr>
                 </a:tc>
               </a:tr>
-              <a:tr h="309676">
+              <a:tr h="295656">
                 <a:tc>
                   <a:txBody>
                     <a:bodyPr wrap="square"/>
@@ -7526,7 +7526,7 @@
                   </a:tcPr>
                 </a:tc>
               </a:tr>
-              <a:tr h="309676">
+              <a:tr h="295656">
                 <a:tc>
                   <a:txBody>
                     <a:bodyPr wrap="square"/>
@@ -7583,7 +7583,7 @@
                   </a:tcPr>
                 </a:tc>
               </a:tr>
-              <a:tr h="309676">
+              <a:tr h="295656">
                 <a:tc>
                   <a:txBody>
                     <a:bodyPr wrap="square"/>
@@ -7640,7 +7640,7 @@
                   </a:tcPr>
                 </a:tc>
               </a:tr>
-              <a:tr h="309676">
+              <a:tr h="295656">
                 <a:tc>
                   <a:txBody>
                     <a:bodyPr wrap="square"/>
@@ -7697,7 +7697,7 @@
                   </a:tcPr>
                 </a:tc>
               </a:tr>
-              <a:tr h="309676">
+              <a:tr h="295656">
                 <a:tc>
                   <a:txBody>
                     <a:bodyPr wrap="square"/>
@@ -7754,7 +7754,7 @@
                   </a:tcPr>
                 </a:tc>
               </a:tr>
-              <a:tr h="309676">
+              <a:tr h="295656">
                 <a:tc>
                   <a:txBody>
                     <a:bodyPr wrap="square"/>
@@ -7811,7 +7811,7 @@
                   </a:tcPr>
                 </a:tc>
               </a:tr>
-              <a:tr h="309676">
+              <a:tr h="295656">
                 <a:tc>
                   <a:txBody>
                     <a:bodyPr wrap="square"/>
@@ -7868,7 +7868,7 @@
                   </a:tcPr>
                 </a:tc>
               </a:tr>
-              <a:tr h="309688">
+              <a:tr h="295656">
                 <a:tc>
                   <a:txBody>
                     <a:bodyPr wrap="square"/>
@@ -8572,8 +8572,8 @@
         </p:blipFill>
         <p:spPr>
           <a:xfrm>
-            <a:off x="310896" y="1709928"/>
-            <a:ext cx="5303520" cy="4754880"/>
+            <a:off x="310896" y="1920240"/>
+            <a:ext cx="5303520" cy="4206240"/>
           </a:xfrm>
           <a:prstGeom prst="rect">
             <a:avLst/>
@@ -8588,8 +8588,8 @@
         </p:nvSpPr>
         <p:spPr>
           <a:xfrm>
-            <a:off x="7379208" y="1709928"/>
-            <a:ext cx="4453128" cy="4754880"/>
+            <a:off x="7379208" y="1920240"/>
+            <a:ext cx="4453128" cy="4206240"/>
           </a:xfrm>
           <a:prstGeom prst="rect">
             <a:avLst/>
@@ -9210,8 +9210,8 @@
         </p:blipFill>
         <p:spPr>
           <a:xfrm>
-            <a:off x="310896" y="1709928"/>
-            <a:ext cx="5303520" cy="4251960"/>
+            <a:off x="310896" y="1920240"/>
+            <a:ext cx="5303520" cy="4206240"/>
           </a:xfrm>
           <a:prstGeom prst="rect">
             <a:avLst/>
@@ -9226,8 +9226,8 @@
         </p:nvSpPr>
         <p:spPr>
           <a:xfrm>
-            <a:off x="4677690" y="2235470"/>
-            <a:ext cx="938832" cy="938832"/>
+            <a:off x="4676933" y="2440131"/>
+            <a:ext cx="928737" cy="928737"/>
           </a:xfrm>
           <a:prstGeom prst="ellipse">
             <a:avLst/>
@@ -9269,8 +9269,8 @@
         </p:nvSpPr>
         <p:spPr>
           <a:xfrm>
-            <a:off x="4677690" y="2291800"/>
-            <a:ext cx="938832" cy="488193"/>
+            <a:off x="4676933" y="2495855"/>
+            <a:ext cx="928737" cy="482943"/>
           </a:xfrm>
           <a:prstGeom prst="rect">
             <a:avLst/>
@@ -9313,8 +9313,8 @@
         </p:nvSpPr>
         <p:spPr>
           <a:xfrm>
-            <a:off x="4489924" y="2761216"/>
-            <a:ext cx="1314365" cy="356756"/>
+            <a:off x="4491186" y="2960224"/>
+            <a:ext cx="1300232" cy="352920"/>
           </a:xfrm>
           <a:prstGeom prst="rect">
             <a:avLst/>
@@ -9348,8 +9348,8 @@
         </p:nvSpPr>
         <p:spPr>
           <a:xfrm>
-            <a:off x="2964942" y="3847133"/>
-            <a:ext cx="844949" cy="844949"/>
+            <a:off x="2964261" y="4034464"/>
+            <a:ext cx="835864" cy="835864"/>
           </a:xfrm>
           <a:prstGeom prst="ellipse">
             <a:avLst/>
@@ -9391,8 +9391,8 @@
         </p:nvSpPr>
         <p:spPr>
           <a:xfrm>
-            <a:off x="2964942" y="3897830"/>
-            <a:ext cx="844949" cy="439373"/>
+            <a:off x="2964261" y="4084616"/>
+            <a:ext cx="835864" cy="434649"/>
           </a:xfrm>
           <a:prstGeom prst="rect">
             <a:avLst/>
@@ -9435,8 +9435,8 @@
         </p:nvSpPr>
         <p:spPr>
           <a:xfrm>
-            <a:off x="2795952" y="4320304"/>
-            <a:ext cx="1182929" cy="321080"/>
+            <a:off x="2797088" y="4502548"/>
+            <a:ext cx="1170209" cy="317628"/>
           </a:xfrm>
           <a:prstGeom prst="rect">
             <a:avLst/>
@@ -9470,8 +9470,8 @@
         </p:nvSpPr>
         <p:spPr>
           <a:xfrm>
-            <a:off x="7379208" y="1709928"/>
-            <a:ext cx="4453128" cy="4251960"/>
+            <a:off x="7379208" y="1920240"/>
+            <a:ext cx="4453128" cy="4206240"/>
           </a:xfrm>
           <a:prstGeom prst="rect">
             <a:avLst/>
@@ -9714,7 +9714,7 @@
         </p:blipFill>
         <p:spPr>
           <a:xfrm>
-            <a:off x="310896" y="1709928"/>
+            <a:off x="310896" y="1920240"/>
             <a:ext cx="5303520" cy="4114800"/>
           </a:xfrm>
           <a:prstGeom prst="rect">
@@ -9730,7 +9730,7 @@
         </p:nvSpPr>
         <p:spPr>
           <a:xfrm>
-            <a:off x="7379208" y="1709928"/>
+            <a:off x="7379208" y="1920240"/>
             <a:ext cx="4453128" cy="4114800"/>
           </a:xfrm>
           <a:prstGeom prst="rect">

</xml_diff>

<commit_message>
Full-width cluster chart, better title wrapping, prominent FIG_W/FIG_H in scripts
- Add _FULL_CHART_W ≈ 12.65" constant; cluster column now fills full slide width
  with no annotation sidebar (annotation panel removed from add_cluster_column_slide)
- Dynamic wrap width in render_cluster_column: max(14, fig_w/n_clusters*14) chars
  — at full width with 7 clusters gives ~25 chars vs the previous hard-coded 14
- _write_chart_script now emits FIG_W and FIG_H as named constants at the top of
  every exported script with a clear "adjust these to resize" comment

https://claude.ai/code/session_01VCXkWfprNAwES9BXV74rqk
</commit_message>
<xml_diff>
--- a/sample_data/wa_energy_output.pptx
+++ b/sample_data/wa_energy_output.pptx
@@ -8203,91 +8203,13 @@
         <p:spPr>
           <a:xfrm>
             <a:off x="310896" y="2061972"/>
-            <a:ext cx="8229600" cy="3931920"/>
+            <a:ext cx="11567160" cy="3931920"/>
           </a:xfrm>
           <a:prstGeom prst="rect">
             <a:avLst/>
           </a:prstGeom>
         </p:spPr>
       </p:pic>
-      <p:sp>
-        <p:nvSpPr>
-          <p:cNvPr id="6" name="TextBox 5"/>
-          <p:cNvSpPr txBox="1"/>
-          <p:nvPr/>
-        </p:nvSpPr>
-        <p:spPr>
-          <a:xfrm>
-            <a:off x="8686800" y="2061972"/>
-            <a:ext cx="3136391" cy="3931920"/>
-          </a:xfrm>
-          <a:prstGeom prst="rect">
-            <a:avLst/>
-          </a:prstGeom>
-          <a:noFill/>
-        </p:spPr>
-        <p:txBody>
-          <a:bodyPr wrap="square">
-            <a:spAutoFit/>
-          </a:bodyPr>
-          <a:lstStyle/>
-          <a:p>
-            <a:r>
-              <a:rPr sz="1400" b="0">
-                <a:solidFill>
-                  <a:srgbClr val="44546A"/>
-                </a:solidFill>
-                <a:latin typeface="DM Sans"/>
-              </a:rPr>
-              <a:t>Younger cohorts are consistently more</a:t>
-            </a:r>
-          </a:p>
-          <a:p>
-            <a:r>
-              <a:rPr sz="1400" b="0">
-                <a:solidFill>
-                  <a:srgbClr val="44546A"/>
-                </a:solidFill>
-                <a:latin typeface="DM Sans"/>
-              </a:rPr>
-              <a:t>optimistic about renewable energy outcomes.</a:t>
-            </a:r>
-          </a:p>
-          <a:p>
-            <a:r>
-              <a:rPr sz="1400" b="0">
-                <a:solidFill>
-                  <a:srgbClr val="44546A"/>
-                </a:solidFill>
-                <a:latin typeface="DM Sans"/>
-              </a:rPr>
-              <a:t/>
-            </a:r>
-          </a:p>
-          <a:p>
-            <a:r>
-              <a:rPr sz="1400" b="0">
-                <a:solidFill>
-                  <a:srgbClr val="00BDBB"/>
-                </a:solidFill>
-                <a:latin typeface="DM Sans"/>
-              </a:rPr>
-              <a:t>  ↑ 18–29 lead on almost every outcome</a:t>
-            </a:r>
-          </a:p>
-          <a:p>
-            <a:r>
-              <a:rPr sz="1400" b="0">
-                <a:solidFill>
-                  <a:srgbClr val="A32015"/>
-                </a:solidFill>
-                <a:latin typeface="DM Sans"/>
-              </a:rPr>
-              <a:t>  ↓ 60+ most sceptical on power prices</a:t>
-            </a:r>
-          </a:p>
-        </p:txBody>
-      </p:sp>
     </p:spTree>
   </p:cSld>
   <p:clrMapOvr>

</xml_diff>

<commit_message>
Data labels font 14 on both new charts; table font 14 with black text
https://claude.ai/code/session_01VCXkWfprNAwES9BXV74rqk
</commit_message>
<xml_diff>
--- a/sample_data/wa_energy_output.pptx
+++ b/sample_data/wa_energy_output.pptx
@@ -7137,18 +7137,18 @@
                     <a:p>
                       <a:pPr algn="l"/>
                       <a:r>
-                        <a:rPr sz="1000" b="1">
+                        <a:rPr sz="1400" b="1">
                           <a:solidFill>
-                            <a:srgbClr val="027F7C"/>
+                            <a:srgbClr val="1A1A1A"/>
                           </a:solidFill>
                           <a:latin typeface="DM Sans"/>
                         </a:rPr>
                         <a:t>Targets create direction and momentum</a:t>
                       </a:r>
                       <a:r>
-                        <a:rPr sz="1000" b="0">
+                        <a:rPr sz="1400" b="0">
                           <a:solidFill>
-                            <a:srgbClr val="027F7C"/>
+                            <a:srgbClr val="1A1A1A"/>
                           </a:solidFill>
                           <a:latin typeface="DM Sans"/>
                         </a:rPr>
@@ -7169,9 +7169,9 @@
                     <a:p>
                       <a:pPr algn="ctr"/>
                       <a:r>
-                        <a:rPr sz="1000" b="1">
+                        <a:rPr sz="1400" b="1">
                           <a:solidFill>
-                            <a:srgbClr val="027F7C"/>
+                            <a:srgbClr val="1A1A1A"/>
                           </a:solidFill>
                           <a:latin typeface="DM Sans"/>
                         </a:rPr>
@@ -7194,18 +7194,18 @@
                     <a:p>
                       <a:pPr algn="l"/>
                       <a:r>
-                        <a:rPr sz="1000" b="1">
+                        <a:rPr sz="1400" b="1">
                           <a:solidFill>
-                            <a:srgbClr val="44546A"/>
+                            <a:srgbClr val="1A1A1A"/>
                           </a:solidFill>
                           <a:latin typeface="DM Sans"/>
                         </a:rPr>
                         <a:t>“Right thing to do” / general support</a:t>
                       </a:r>
                       <a:r>
-                        <a:rPr sz="1000" b="0">
+                        <a:rPr sz="1400" b="0">
                           <a:solidFill>
-                            <a:srgbClr val="44546A"/>
+                            <a:srgbClr val="1A1A1A"/>
                           </a:solidFill>
                           <a:latin typeface="DM Sans"/>
                         </a:rPr>
@@ -7226,9 +7226,9 @@
                     <a:p>
                       <a:pPr algn="ctr"/>
                       <a:r>
-                        <a:rPr sz="1000" b="1">
+                        <a:rPr sz="1400" b="1">
                           <a:solidFill>
-                            <a:srgbClr val="027F7C"/>
+                            <a:srgbClr val="1A1A1A"/>
                           </a:solidFill>
                           <a:latin typeface="DM Sans"/>
                         </a:rPr>
@@ -7251,18 +7251,18 @@
                     <a:p>
                       <a:pPr algn="l"/>
                       <a:r>
-                        <a:rPr sz="1000" b="1">
+                        <a:rPr sz="1400" b="1">
                           <a:solidFill>
-                            <a:srgbClr val="44546A"/>
+                            <a:srgbClr val="1A1A1A"/>
                           </a:solidFill>
                           <a:latin typeface="DM Sans"/>
                         </a:rPr>
                         <a:t>Better environment and health outcomes</a:t>
                       </a:r>
                       <a:r>
-                        <a:rPr sz="1000" b="0">
+                        <a:rPr sz="1400" b="0">
                           <a:solidFill>
-                            <a:srgbClr val="44546A"/>
+                            <a:srgbClr val="1A1A1A"/>
                           </a:solidFill>
                           <a:latin typeface="DM Sans"/>
                         </a:rPr>
@@ -7283,9 +7283,9 @@
                     <a:p>
                       <a:pPr algn="ctr"/>
                       <a:r>
-                        <a:rPr sz="1000" b="1">
+                        <a:rPr sz="1400" b="1">
                           <a:solidFill>
-                            <a:srgbClr val="44546A"/>
+                            <a:srgbClr val="1A1A1A"/>
                           </a:solidFill>
                           <a:latin typeface="DM Sans"/>
                         </a:rPr>
@@ -7308,18 +7308,18 @@
                     <a:p>
                       <a:pPr algn="l"/>
                       <a:r>
-                        <a:rPr sz="1000" b="1">
+                        <a:rPr sz="1400" b="1">
                           <a:solidFill>
-                            <a:srgbClr val="44546A"/>
+                            <a:srgbClr val="1A1A1A"/>
                           </a:solidFill>
                           <a:latin typeface="DM Sans"/>
                         </a:rPr>
                         <a:t>Climate change and emissions reduction</a:t>
                       </a:r>
                       <a:r>
-                        <a:rPr sz="1000" b="0">
+                        <a:rPr sz="1400" b="0">
                           <a:solidFill>
-                            <a:srgbClr val="44546A"/>
+                            <a:srgbClr val="1A1A1A"/>
                           </a:solidFill>
                           <a:latin typeface="DM Sans"/>
                         </a:rPr>
@@ -7340,9 +7340,9 @@
                     <a:p>
                       <a:pPr algn="ctr"/>
                       <a:r>
-                        <a:rPr sz="1000" b="1">
+                        <a:rPr sz="1400" b="1">
                           <a:solidFill>
-                            <a:srgbClr val="44546A"/>
+                            <a:srgbClr val="1A1A1A"/>
                           </a:solidFill>
                           <a:latin typeface="DM Sans"/>
                         </a:rPr>
@@ -7365,18 +7365,18 @@
                     <a:p>
                       <a:pPr algn="l"/>
                       <a:r>
-                        <a:rPr sz="1000" b="1">
+                        <a:rPr sz="1400" b="1">
                           <a:solidFill>
-                            <a:srgbClr val="44546A"/>
+                            <a:srgbClr val="1A1A1A"/>
                           </a:solidFill>
                           <a:latin typeface="DM Sans"/>
                         </a:rPr>
                         <a:t>Reduce reliance on fossil fuels</a:t>
                       </a:r>
                       <a:r>
-                        <a:rPr sz="1000" b="0">
+                        <a:rPr sz="1400" b="0">
                           <a:solidFill>
-                            <a:srgbClr val="44546A"/>
+                            <a:srgbClr val="1A1A1A"/>
                           </a:solidFill>
                           <a:latin typeface="DM Sans"/>
                         </a:rPr>
@@ -7397,9 +7397,9 @@
                     <a:p>
                       <a:pPr algn="ctr"/>
                       <a:r>
-                        <a:rPr sz="1000" b="1">
+                        <a:rPr sz="1400" b="1">
                           <a:solidFill>
-                            <a:srgbClr val="44546A"/>
+                            <a:srgbClr val="1A1A1A"/>
                           </a:solidFill>
                           <a:latin typeface="DM Sans"/>
                         </a:rPr>
@@ -7422,18 +7422,18 @@
                     <a:p>
                       <a:pPr algn="l"/>
                       <a:r>
-                        <a:rPr sz="1000" b="1">
+                        <a:rPr sz="1400" b="1">
                           <a:solidFill>
-                            <a:srgbClr val="44546A"/>
+                            <a:srgbClr val="1A1A1A"/>
                           </a:solidFill>
                           <a:latin typeface="DM Sans"/>
                         </a:rPr>
                         <a:t>Accountability and measurement</a:t>
                       </a:r>
                       <a:r>
-                        <a:rPr sz="1000" b="0">
+                        <a:rPr sz="1400" b="0">
                           <a:solidFill>
-                            <a:srgbClr val="44546A"/>
+                            <a:srgbClr val="1A1A1A"/>
                           </a:solidFill>
                           <a:latin typeface="DM Sans"/>
                         </a:rPr>
@@ -7454,9 +7454,9 @@
                     <a:p>
                       <a:pPr algn="ctr"/>
                       <a:r>
-                        <a:rPr sz="1000" b="1">
+                        <a:rPr sz="1400" b="1">
                           <a:solidFill>
-                            <a:srgbClr val="44546A"/>
+                            <a:srgbClr val="1A1A1A"/>
                           </a:solidFill>
                           <a:latin typeface="DM Sans"/>
                         </a:rPr>
@@ -7479,18 +7479,18 @@
                     <a:p>
                       <a:pPr algn="l"/>
                       <a:r>
-                        <a:rPr sz="1000" b="1">
+                        <a:rPr sz="1400" b="1">
                           <a:solidFill>
-                            <a:srgbClr val="44546A"/>
+                            <a:srgbClr val="1A1A1A"/>
                           </a:solidFill>
                           <a:latin typeface="DM Sans"/>
                         </a:rPr>
                         <a:t>Cost of living and cheaper power over time</a:t>
                       </a:r>
                       <a:r>
-                        <a:rPr sz="1000" b="0">
+                        <a:rPr sz="1400" b="0">
                           <a:solidFill>
-                            <a:srgbClr val="44546A"/>
+                            <a:srgbClr val="1A1A1A"/>
                           </a:solidFill>
                           <a:latin typeface="DM Sans"/>
                         </a:rPr>
@@ -7511,9 +7511,9 @@
                     <a:p>
                       <a:pPr algn="ctr"/>
                       <a:r>
-                        <a:rPr sz="1000" b="1">
+                        <a:rPr sz="1400" b="1">
                           <a:solidFill>
-                            <a:srgbClr val="44546A"/>
+                            <a:srgbClr val="1A1A1A"/>
                           </a:solidFill>
                           <a:latin typeface="DM Sans"/>
                         </a:rPr>
@@ -7536,18 +7536,18 @@
                     <a:p>
                       <a:pPr algn="l"/>
                       <a:r>
-                        <a:rPr sz="1000" b="1">
+                        <a:rPr sz="1400" b="1">
                           <a:solidFill>
-                            <a:srgbClr val="44546A"/>
+                            <a:srgbClr val="1A1A1A"/>
                           </a:solidFill>
                           <a:latin typeface="DM Sans"/>
                         </a:rPr>
                         <a:t>Future generations</a:t>
                       </a:r>
                       <a:r>
-                        <a:rPr sz="1000" b="0">
+                        <a:rPr sz="1400" b="0">
                           <a:solidFill>
-                            <a:srgbClr val="44546A"/>
+                            <a:srgbClr val="1A1A1A"/>
                           </a:solidFill>
                           <a:latin typeface="DM Sans"/>
                         </a:rPr>
@@ -7568,9 +7568,9 @@
                     <a:p>
                       <a:pPr algn="ctr"/>
                       <a:r>
-                        <a:rPr sz="1000" b="1">
+                        <a:rPr sz="1400" b="1">
                           <a:solidFill>
-                            <a:srgbClr val="44546A"/>
+                            <a:srgbClr val="1A1A1A"/>
                           </a:solidFill>
                           <a:latin typeface="DM Sans"/>
                         </a:rPr>
@@ -7593,18 +7593,18 @@
                     <a:p>
                       <a:pPr algn="l"/>
                       <a:r>
-                        <a:rPr sz="1000" b="1">
+                        <a:rPr sz="1400" b="1">
                           <a:solidFill>
-                            <a:srgbClr val="44546A"/>
+                            <a:srgbClr val="1A1A1A"/>
                           </a:solidFill>
                           <a:latin typeface="DM Sans"/>
                         </a:rPr>
                         <a:t>Conditional support focused on feasibility</a:t>
                       </a:r>
                       <a:r>
-                        <a:rPr sz="1000" b="0">
+                        <a:rPr sz="1400" b="0">
                           <a:solidFill>
-                            <a:srgbClr val="44546A"/>
+                            <a:srgbClr val="1A1A1A"/>
                           </a:solidFill>
                           <a:latin typeface="DM Sans"/>
                         </a:rPr>
@@ -7625,9 +7625,9 @@
                     <a:p>
                       <a:pPr algn="ctr"/>
                       <a:r>
-                        <a:rPr sz="1000" b="1">
+                        <a:rPr sz="1400" b="1">
                           <a:solidFill>
-                            <a:srgbClr val="44546A"/>
+                            <a:srgbClr val="1A1A1A"/>
                           </a:solidFill>
                           <a:latin typeface="DM Sans"/>
                         </a:rPr>
@@ -7650,18 +7650,18 @@
                     <a:p>
                       <a:pPr algn="l"/>
                       <a:r>
-                        <a:rPr sz="1000" b="1">
+                        <a:rPr sz="1400" b="1">
                           <a:solidFill>
-                            <a:srgbClr val="44546A"/>
+                            <a:srgbClr val="1A1A1A"/>
                           </a:solidFill>
                           <a:latin typeface="DM Sans"/>
                         </a:rPr>
                         <a:t>Economic opportunity and jobs</a:t>
                       </a:r>
                       <a:r>
-                        <a:rPr sz="1000" b="0">
+                        <a:rPr sz="1400" b="0">
                           <a:solidFill>
-                            <a:srgbClr val="44546A"/>
+                            <a:srgbClr val="1A1A1A"/>
                           </a:solidFill>
                           <a:latin typeface="DM Sans"/>
                         </a:rPr>
@@ -7682,9 +7682,9 @@
                     <a:p>
                       <a:pPr algn="ctr"/>
                       <a:r>
-                        <a:rPr sz="1000" b="1">
+                        <a:rPr sz="1400" b="1">
                           <a:solidFill>
-                            <a:srgbClr val="44546A"/>
+                            <a:srgbClr val="1A1A1A"/>
                           </a:solidFill>
                           <a:latin typeface="DM Sans"/>
                         </a:rPr>
@@ -7707,18 +7707,18 @@
                     <a:p>
                       <a:pPr algn="l"/>
                       <a:r>
-                        <a:rPr sz="1000" b="1">
+                        <a:rPr sz="1400" b="1">
                           <a:solidFill>
-                            <a:srgbClr val="44546A"/>
+                            <a:srgbClr val="1A1A1A"/>
                           </a:solidFill>
                           <a:latin typeface="DM Sans"/>
                         </a:rPr>
                         <a:t>Energy security and reliability</a:t>
                       </a:r>
                       <a:r>
-                        <a:rPr sz="1000" b="0">
+                        <a:rPr sz="1400" b="0">
                           <a:solidFill>
-                            <a:srgbClr val="44546A"/>
+                            <a:srgbClr val="1A1A1A"/>
                           </a:solidFill>
                           <a:latin typeface="DM Sans"/>
                         </a:rPr>
@@ -7739,9 +7739,9 @@
                     <a:p>
                       <a:pPr algn="ctr"/>
                       <a:r>
-                        <a:rPr sz="1000" b="1">
+                        <a:rPr sz="1400" b="1">
                           <a:solidFill>
-                            <a:srgbClr val="44546A"/>
+                            <a:srgbClr val="1A1A1A"/>
                           </a:solidFill>
                           <a:latin typeface="DM Sans"/>
                         </a:rPr>
@@ -7764,18 +7764,18 @@
                     <a:p>
                       <a:pPr algn="l"/>
                       <a:r>
-                        <a:rPr sz="1000" b="1">
+                        <a:rPr sz="1400" b="1">
                           <a:solidFill>
-                            <a:srgbClr val="44546A"/>
+                            <a:srgbClr val="1A1A1A"/>
                           </a:solidFill>
                           <a:latin typeface="DM Sans"/>
                         </a:rPr>
                         <a:t>Dissatisfaction with politics or delivery</a:t>
                       </a:r>
                       <a:r>
-                        <a:rPr sz="1000" b="0">
+                        <a:rPr sz="1400" b="0">
                           <a:solidFill>
-                            <a:srgbClr val="44546A"/>
+                            <a:srgbClr val="1A1A1A"/>
                           </a:solidFill>
                           <a:latin typeface="DM Sans"/>
                         </a:rPr>
@@ -7796,9 +7796,9 @@
                     <a:p>
                       <a:pPr algn="ctr"/>
                       <a:r>
-                        <a:rPr sz="1000" b="1">
+                        <a:rPr sz="1400" b="1">
                           <a:solidFill>
-                            <a:srgbClr val="44546A"/>
+                            <a:srgbClr val="1A1A1A"/>
                           </a:solidFill>
                           <a:latin typeface="DM Sans"/>
                         </a:rPr>
@@ -7821,18 +7821,18 @@
                     <a:p>
                       <a:pPr algn="l"/>
                       <a:r>
-                        <a:rPr sz="1000" b="1">
+                        <a:rPr sz="1400" b="1">
                           <a:solidFill>
-                            <a:srgbClr val="44546A"/>
+                            <a:srgbClr val="1A1A1A"/>
                           </a:solidFill>
                           <a:latin typeface="DM Sans"/>
                         </a:rPr>
                         <a:t>Certainty for planning and investment</a:t>
                       </a:r>
                       <a:r>
-                        <a:rPr sz="1000" b="0">
+                        <a:rPr sz="1400" b="0">
                           <a:solidFill>
-                            <a:srgbClr val="44546A"/>
+                            <a:srgbClr val="1A1A1A"/>
                           </a:solidFill>
                           <a:latin typeface="DM Sans"/>
                         </a:rPr>
@@ -7853,9 +7853,9 @@
                     <a:p>
                       <a:pPr algn="ctr"/>
                       <a:r>
-                        <a:rPr sz="1000" b="1">
+                        <a:rPr sz="1400" b="1">
                           <a:solidFill>
-                            <a:srgbClr val="44546A"/>
+                            <a:srgbClr val="1A1A1A"/>
                           </a:solidFill>
                           <a:latin typeface="DM Sans"/>
                         </a:rPr>
@@ -7878,9 +7878,9 @@
                     <a:p>
                       <a:pPr algn="l"/>
                       <a:r>
-                        <a:rPr sz="1000" b="1">
+                        <a:rPr sz="1400" b="1">
                           <a:solidFill>
-                            <a:srgbClr val="44546A"/>
+                            <a:srgbClr val="1A1A1A"/>
                           </a:solidFill>
                           <a:latin typeface="DM Sans"/>
                         </a:rPr>
@@ -7901,9 +7901,9 @@
                     <a:p>
                       <a:pPr algn="ctr"/>
                       <a:r>
-                        <a:rPr sz="1000" b="1">
+                        <a:rPr sz="1400" b="1">
                           <a:solidFill>
-                            <a:srgbClr val="44546A"/>
+                            <a:srgbClr val="1A1A1A"/>
                           </a:solidFill>
                           <a:latin typeface="DM Sans"/>
                         </a:rPr>

</xml_diff>